<commit_message>
Rosal BI 0.5.0: rediseño, estadística real, IA conectada, docs actualizados
- Motor estadístico real (desviación estándar, correlación, atípicos)
- Proyecciones con rango de confianza
- Chat con IA real (Narrador Experto) vía n8n, con memoria de conversación
- Corrige bug: columnas tipo tasa se sumaban en vez de promediarse
- Corrige bug: el webhook de n8n leía el body en el lugar equivocado
- Documentación actualizada (arquitectura, manual, metodología, roadmap)
- Presentación con logo real integrado
</commit_message>
<xml_diff>
--- a/presentacion/El_Rosal_Lienzo_Ejecutivo.pptx
+++ b/presentacion/El_Rosal_Lienzo_Ejecutivo.pptx
@@ -951,7 +951,7 @@
           <a:p>
             <a:r>
               <a:rPr lang="en-US" dirty="0"/>
-              <a:t>(4:30 - 5:45) El rigor técnico es el núcleo de la aplicación. Al cargar los datos, el algoritmo hace un muestreo y perfila cada columna clasificándola en Fecha, Dimensión o Medida. Esto no es una plantilla fija; el sistema construye agregaciones matemáticas dinámicas. Si detecta una columna de 'Edad', agrupa en rangos. Si detecta un código de departamento, lo ignora para sumas. El análisis se adapta estadísticamente a la estructura de la tabla.</a:t>
+              <a:t>(4:30 - 5:45) El rigor técnico es el núcleo de la aplicación. Al cargar los datos, el algoritmo hace un muestreo y perfila cada columna clasificándola en Fecha, Dimensión o Medida. Esto no es una plantilla fija; el sistema construye agregaciones matemáticas dinámicas, y además calcula estadística real: desviación estándar, correlación entre variables cuando hay más de una medida, y detección automática de valores atípicos — todo esto en menos de 100 milisegundos, incluso con 10.000 filas.</a:t>
             </a:r>
             <a:endParaRPr lang="en-US" dirty="0"/>
           </a:p>
@@ -1039,7 +1039,7 @@
           <a:p>
             <a:r>
               <a:rPr lang="en-US" dirty="0"/>
-              <a:t>(5:45 - 7:15) Aplicamos IA de tres formas. Primero, un motor heurístico evalúa las combinaciones lógicas y te sugiere: 'Basado en tus datos, lo más relevante es esta tendencia y este Top 10'. Segundo, implementamos análisis predictivo: si hay datos históricos, el sistema calcula la tasa de crecimiento promedio y proyecta matemáticamente el siguiente periodo, marcándolo con un badge de 'Estimado'. Tercero, inteligencia de diseño: el lienzo se acomoda solo para no dejar espacios vacíos, combinando automatización con el control manual del usuario.</a:t>
+              <a:t>(5:45 - 7:15) Aplicamos IA de tres formas, siempre con la misma regla: la IA nunca calcula ni inventa una cifra, solo interpreta lo que ya calculamos de forma determinista. Primero, un motor heurístico sugiere los KPIs y gráficos más relevantes. Segundo, un análisis predictivo que no finge una precisión falsa: proyecta el próximo periodo con un rango de confianza, más ancho si la tendencia ha sido volátil. Tercero, y el más nuevo: un 'Narrador Experto' con un modelo de lenguaje real, conectado vía n8n, que recibe únicamente los números que ya calculamos y los explica con contexto institucional — qué hace el DANE, cómo opera el SGP, qué es el PAE — sin nunca inventar una cifra que no le hayamos dado.</a:t>
             </a:r>
             <a:endParaRPr lang="en-US" dirty="0"/>
           </a:p>
@@ -1127,7 +1127,7 @@
           <a:p>
             <a:r>
               <a:rPr lang="en-US" dirty="0"/>
-              <a:t>(7:15 - 8:30) La usabilidad es de grado empresarial. El usuario revisa su plan en una interfaz limpia, selecciona qué elementos incluir, y con un clic genera el lienzo. Para la exportación, implementamos una lógica de 'Slicing' que divide el lienzo en páginas A4 horizontales en alta resolución, listas para imprimir o llevar a una consejería. La información no se deforma, se comunica con claridad.</a:t>
+              <a:t>(7:15 - 8:30) La usabilidad es de grado empresarial. El usuario revisa su plan en una interfaz limpia, selecciona qué elementos incluir, y con un clic genera el lienzo. Para la exportación, implementamos una lógica de 'Slicing' que divide el lienzo en páginas A4 horizontales en alta resolución, listas para imprimir. Y la interfaz completa es responsive: funciona igual de bien en un computador, una tablet o el celular de un ciudadano.</a:t>
             </a:r>
             <a:endParaRPr lang="en-US" dirty="0"/>
           </a:p>
@@ -1303,7 +1303,7 @@
           <a:p>
             <a:r>
               <a:rPr lang="en-US" dirty="0"/>
-              <a:t>(9:30 - 9:50) Para concluir, les voy a mostrar lo fácil que es. [Buscas 'Educación' o 'Morbilidad' en la app, haces clic en un dataset, esperas a que cargue el plan, clicas en 'Generar Lienzo', y luego en 'Descargar PDF']. Como ven, en menos de un minuto transformamos una tabla cruda en un informe ejecutivo listo para gobernar.</a:t>
+              <a:t>(9:30 - 9:50) Para concluir, les voy a mostrar lo fácil que es. [Buscas 'Educación' o 'Morbilidad' en la app, haces clic en un dataset, esperas a que cargue el plan, clicas en 'Generar Lienzo', le preguntas algo al Narrador Experto en el chat, y luego le das a 'Descargar PDF']. Como ven, en menos de un minuto transformamos una tabla cruda en un informe ejecutivo listo para gobernar — con una IA real explicándolo, no solo un dashboard.</a:t>
             </a:r>
             <a:endParaRPr lang="en-US" dirty="0"/>
           </a:p>
@@ -1684,214 +1684,21 @@
         </p:nvSpPr>
         <p:spPr>
           <a:xfrm>
-            <a:off x="8778240" y="-2011680"/>
-            <a:ext cx="5943600" cy="5943600"/>
-          </a:xfrm>
-          <a:prstGeom prst="ellipse">
-            <a:avLst/>
-          </a:prstGeom>
-          <a:solidFill>
-            <a:srgbClr val="1E3A5F">
-              <a:alpha val="45000"/>
-            </a:srgbClr>
-          </a:solidFill>
-          <a:ln/>
-        </p:spPr>
-      </p:sp>
-      <p:sp>
-        <p:nvSpPr>
-          <p:cNvPr id="3" name="Shape 1"/>
-          <p:cNvSpPr/>
-          <p:nvPr/>
-        </p:nvSpPr>
-        <p:spPr>
-          <a:xfrm>
-            <a:off x="-2286000" y="4206240"/>
-            <a:ext cx="4754880" cy="4754880"/>
-          </a:xfrm>
-          <a:prstGeom prst="ellipse">
-            <a:avLst/>
-          </a:prstGeom>
-          <a:solidFill>
-            <a:srgbClr val="0EA5E9">
-              <a:alpha val="12000"/>
-            </a:srgbClr>
-          </a:solidFill>
-          <a:ln/>
-        </p:spPr>
-      </p:sp>
-      <p:sp>
-        <p:nvSpPr>
-          <p:cNvPr id="4" name="Text 2"/>
-          <p:cNvSpPr/>
-          <p:nvPr/>
-        </p:nvSpPr>
-        <p:spPr>
-          <a:xfrm>
-            <a:off x="822960" y="1417320"/>
-            <a:ext cx="9144000" cy="365760"/>
-          </a:xfrm>
-          <a:prstGeom prst="rect">
-            <a:avLst/>
-          </a:prstGeom>
-          <a:noFill/>
-          <a:ln/>
-        </p:spPr>
-        <p:txBody>
-          <a:bodyPr wrap="square" lIns="0" tIns="0" rIns="0" bIns="0" rtlCol="0" anchor="ctr"/>
-          <a:lstStyle/>
-          <a:p>
-            <a:pPr indent="0" marL="0">
-              <a:buNone/>
-            </a:pPr>
-            <a:r>
-              <a:rPr lang="en-US" sz="1300" b="1" spc="200" kern="0" dirty="0">
-                <a:solidFill>
-                  <a:srgbClr val="0EA5E9"/>
-                </a:solidFill>
-                <a:latin typeface="Segoe UI" pitchFamily="34" charset="0"/>
-                <a:ea typeface="Segoe UI" pitchFamily="34" charset="-122"/>
-                <a:cs typeface="Segoe UI" pitchFamily="34" charset="-120"/>
-              </a:rPr>
-              <a:t>MUNICIPIO DE EL ROSAL, CUNDINAMARCA</a:t>
-            </a:r>
-            <a:endParaRPr lang="en-US" sz="1300" dirty="0"/>
-          </a:p>
-        </p:txBody>
-      </p:sp>
-      <p:sp>
-        <p:nvSpPr>
-          <p:cNvPr id="5" name="Text 3"/>
-          <p:cNvSpPr/>
-          <p:nvPr/>
-        </p:nvSpPr>
-        <p:spPr>
-          <a:xfrm>
-            <a:off x="822960" y="1874520"/>
-            <a:ext cx="9875520" cy="2103120"/>
-          </a:xfrm>
-          <a:prstGeom prst="rect">
-            <a:avLst/>
-          </a:prstGeom>
-          <a:noFill/>
-          <a:ln/>
-        </p:spPr>
-        <p:txBody>
-          <a:bodyPr wrap="square" lIns="0" tIns="0" rIns="0" bIns="0" rtlCol="0" anchor="ctr"/>
-          <a:lstStyle/>
-          <a:p>
-            <a:pPr indent="0" marL="0">
-              <a:lnSpc>
-                <a:spcPts val="4600"/>
-              </a:lnSpc>
-              <a:buNone/>
-            </a:pPr>
-            <a:r>
-              <a:rPr lang="en-US" sz="4200" b="1" dirty="0">
-                <a:solidFill>
-                  <a:srgbClr val="FFFFFF"/>
-                </a:solidFill>
-                <a:latin typeface="Segoe UI" pitchFamily="34" charset="0"/>
-                <a:ea typeface="Segoe UI" pitchFamily="34" charset="-122"/>
-                <a:cs typeface="Segoe UI" pitchFamily="34" charset="-120"/>
-              </a:rPr>
-              <a:t>Del Dato Crudo a la Decisión:</a:t>
-            </a:r>
-            <a:endParaRPr lang="en-US" sz="4200" dirty="0"/>
-          </a:p>
-          <a:p>
-            <a:pPr indent="0" marL="0">
-              <a:lnSpc>
-                <a:spcPts val="4600"/>
-              </a:lnSpc>
-              <a:buNone/>
-            </a:pPr>
-            <a:r>
-              <a:rPr lang="en-US" sz="4200" b="1" dirty="0">
-                <a:solidFill>
-                  <a:srgbClr val="FFFFFF"/>
-                </a:solidFill>
-                <a:latin typeface="Segoe UI" pitchFamily="34" charset="0"/>
-                <a:ea typeface="Segoe UI" pitchFamily="34" charset="-122"/>
-                <a:cs typeface="Segoe UI" pitchFamily="34" charset="-120"/>
-              </a:rPr>
-              <a:t>Lienzos Ejecutivos con IA</a:t>
-            </a:r>
-            <a:endParaRPr lang="en-US" sz="4200" dirty="0"/>
-          </a:p>
-        </p:txBody>
-      </p:sp>
-      <p:sp>
-        <p:nvSpPr>
-          <p:cNvPr id="6" name="Text 4"/>
-          <p:cNvSpPr/>
-          <p:nvPr/>
-        </p:nvSpPr>
-        <p:spPr>
-          <a:xfrm>
-            <a:off x="822960" y="3977640"/>
-            <a:ext cx="8686800" cy="457200"/>
-          </a:xfrm>
-          <a:prstGeom prst="rect">
-            <a:avLst/>
-          </a:prstGeom>
-          <a:noFill/>
-          <a:ln/>
-        </p:spPr>
-        <p:txBody>
-          <a:bodyPr wrap="square" lIns="0" tIns="0" rIns="0" bIns="0" rtlCol="0" anchor="ctr"/>
-          <a:lstStyle/>
-          <a:p>
-            <a:pPr indent="0" marL="0">
-              <a:buNone/>
-            </a:pPr>
-            <a:r>
-              <a:rPr lang="en-US" sz="1600" dirty="0">
-                <a:solidFill>
-                  <a:srgbClr val="CBD5E1"/>
-                </a:solidFill>
-                <a:latin typeface="Segoe UI" pitchFamily="34" charset="0"/>
-                <a:ea typeface="Segoe UI" pitchFamily="34" charset="-122"/>
-                <a:cs typeface="Segoe UI" pitchFamily="34" charset="-120"/>
-              </a:rPr>
-              <a:t>Concurso Datos al Ecosistema 2026 · Innovación y Tecnología</a:t>
-            </a:r>
-            <a:endParaRPr lang="en-US" sz="1600" dirty="0"/>
-          </a:p>
-        </p:txBody>
-      </p:sp>
-      <p:sp>
-        <p:nvSpPr>
-          <p:cNvPr id="7" name="Shape 5"/>
-          <p:cNvSpPr/>
-          <p:nvPr/>
-        </p:nvSpPr>
-        <p:spPr>
-          <a:xfrm>
-            <a:off x="822960" y="4892040"/>
-            <a:ext cx="777240" cy="777240"/>
-          </a:xfrm>
-          <a:prstGeom prst="roundRect">
-            <a:avLst>
-              <a:gd name="adj" fmla="val 21176"/>
-            </a:avLst>
-          </a:prstGeom>
-          <a:solidFill>
-            <a:srgbClr val="FFFFFF">
-              <a:alpha val="10000"/>
-            </a:srgbClr>
-          </a:solidFill>
-          <a:ln w="15875">
-            <a:solidFill>
-              <a:srgbClr val="0EA5E9"/>
-            </a:solidFill>
-            <a:prstDash val="solid"/>
-          </a:ln>
+            <a:off x="8686800" y="0"/>
+            <a:ext cx="3502152" cy="6858000"/>
+          </a:xfrm>
+          <a:prstGeom prst="rect">
+            <a:avLst/>
+          </a:prstGeom>
+          <a:solidFill>
+            <a:srgbClr val="FFFFFF"/>
+          </a:solidFill>
+          <a:ln/>
         </p:spPr>
       </p:sp>
       <p:pic>
         <p:nvPicPr>
-          <p:cNvPr id="8" name="Image 0" descr="/home/claude/pptx-lienzo/icons/grid.png">    </p:cNvPr>
+          <p:cNvPr id="3" name="Image 0" descr="/home/claude/pptx-lienzo/logo/logo-completo-verificado.png">    </p:cNvPr>
           <p:cNvPicPr>
             <a:picLocks noChangeAspect="1"/>
           </p:cNvPicPr>
@@ -1905,8 +1712,8 @@
         </p:blipFill>
         <p:spPr>
           <a:xfrm>
-            <a:off x="1014984" y="5084064"/>
-            <a:ext cx="393192" cy="393192"/>
+            <a:off x="9249156" y="1983020"/>
+            <a:ext cx="2377440" cy="2891961"/>
           </a:xfrm>
           <a:prstGeom prst="rect">
             <a:avLst/>
@@ -1915,85 +1722,205 @@
       </p:pic>
       <p:sp>
         <p:nvSpPr>
+          <p:cNvPr id="4" name="Text 1"/>
+          <p:cNvSpPr/>
+          <p:nvPr/>
+        </p:nvSpPr>
+        <p:spPr>
+          <a:xfrm>
+            <a:off x="822960" y="1051560"/>
+            <a:ext cx="7498080" cy="365760"/>
+          </a:xfrm>
+          <a:prstGeom prst="rect">
+            <a:avLst/>
+          </a:prstGeom>
+          <a:noFill/>
+          <a:ln/>
+        </p:spPr>
+        <p:txBody>
+          <a:bodyPr wrap="square" lIns="0" tIns="0" rIns="0" bIns="0" rtlCol="0" anchor="ctr"/>
+          <a:lstStyle/>
+          <a:p>
+            <a:pPr indent="0" marL="0">
+              <a:buNone/>
+            </a:pPr>
+            <a:r>
+              <a:rPr lang="en-US" sz="1300" b="1" spc="200" kern="0" dirty="0">
+                <a:solidFill>
+                  <a:srgbClr val="0EA5E9"/>
+                </a:solidFill>
+                <a:latin typeface="Segoe UI" pitchFamily="34" charset="0"/>
+                <a:ea typeface="Segoe UI" pitchFamily="34" charset="-122"/>
+                <a:cs typeface="Segoe UI" pitchFamily="34" charset="-120"/>
+              </a:rPr>
+              <a:t>MUNICIPIO DE EL ROSAL, CUNDINAMARCA</a:t>
+            </a:r>
+            <a:endParaRPr lang="en-US" sz="1300" dirty="0"/>
+          </a:p>
+        </p:txBody>
+      </p:sp>
+      <p:sp>
+        <p:nvSpPr>
+          <p:cNvPr id="5" name="Text 2"/>
+          <p:cNvSpPr/>
+          <p:nvPr/>
+        </p:nvSpPr>
+        <p:spPr>
+          <a:xfrm>
+            <a:off x="822960" y="1481328"/>
+            <a:ext cx="7498080" cy="777240"/>
+          </a:xfrm>
+          <a:prstGeom prst="rect">
+            <a:avLst/>
+          </a:prstGeom>
+          <a:noFill/>
+          <a:ln/>
+        </p:spPr>
+        <p:txBody>
+          <a:bodyPr wrap="square" lIns="0" tIns="0" rIns="0" bIns="0" rtlCol="0" anchor="ctr"/>
+          <a:lstStyle/>
+          <a:p>
+            <a:pPr indent="0" marL="0">
+              <a:buNone/>
+            </a:pPr>
+            <a:r>
+              <a:rPr lang="en-US" sz="4600" b="1" dirty="0">
+                <a:solidFill>
+                  <a:srgbClr val="FFFFFF"/>
+                </a:solidFill>
+                <a:latin typeface="Segoe UI" pitchFamily="34" charset="0"/>
+                <a:ea typeface="Segoe UI" pitchFamily="34" charset="-122"/>
+                <a:cs typeface="Segoe UI" pitchFamily="34" charset="-120"/>
+              </a:rPr>
+              <a:t>Rosal BI.</a:t>
+            </a:r>
+            <a:endParaRPr lang="en-US" sz="4600" dirty="0"/>
+          </a:p>
+        </p:txBody>
+      </p:sp>
+      <p:sp>
+        <p:nvSpPr>
+          <p:cNvPr id="6" name="Text 3"/>
+          <p:cNvSpPr/>
+          <p:nvPr/>
+        </p:nvSpPr>
+        <p:spPr>
+          <a:xfrm>
+            <a:off x="822960" y="2212848"/>
+            <a:ext cx="7498080" cy="365760"/>
+          </a:xfrm>
+          <a:prstGeom prst="rect">
+            <a:avLst/>
+          </a:prstGeom>
+          <a:noFill/>
+          <a:ln/>
+        </p:spPr>
+        <p:txBody>
+          <a:bodyPr wrap="square" lIns="0" tIns="0" rIns="0" bIns="0" rtlCol="0" anchor="ctr"/>
+          <a:lstStyle/>
+          <a:p>
+            <a:pPr indent="0" marL="0">
+              <a:buNone/>
+            </a:pPr>
+            <a:r>
+              <a:rPr lang="en-US" sz="1600" b="1" spc="100" kern="0" dirty="0">
+                <a:solidFill>
+                  <a:srgbClr val="FFFFFF"/>
+                </a:solidFill>
+                <a:latin typeface="Segoe UI" pitchFamily="34" charset="0"/>
+                <a:ea typeface="Segoe UI" pitchFamily="34" charset="-122"/>
+                <a:cs typeface="Segoe UI" pitchFamily="34" charset="-120"/>
+              </a:rPr>
+              <a:t>DATOS QUE TRANSFORMAN</a:t>
+            </a:r>
+            <a:endParaRPr lang="en-US" sz="1600" dirty="0"/>
+          </a:p>
+        </p:txBody>
+      </p:sp>
+      <p:sp>
+        <p:nvSpPr>
+          <p:cNvPr id="7" name="Text 4"/>
+          <p:cNvSpPr/>
+          <p:nvPr/>
+        </p:nvSpPr>
+        <p:spPr>
+          <a:xfrm>
+            <a:off x="822960" y="2880360"/>
+            <a:ext cx="7315200" cy="1188720"/>
+          </a:xfrm>
+          <a:prstGeom prst="rect">
+            <a:avLst/>
+          </a:prstGeom>
+          <a:noFill/>
+          <a:ln/>
+        </p:spPr>
+        <p:txBody>
+          <a:bodyPr wrap="square" lIns="0" tIns="0" rIns="0" bIns="0" rtlCol="0" anchor="ctr"/>
+          <a:lstStyle/>
+          <a:p>
+            <a:pPr indent="0" marL="0">
+              <a:lnSpc>
+                <a:spcPct val="130000"/>
+              </a:lnSpc>
+              <a:buNone/>
+            </a:pPr>
+            <a:r>
+              <a:rPr lang="en-US" sz="1400" i="1" dirty="0">
+                <a:solidFill>
+                  <a:srgbClr val="CBD5E1"/>
+                </a:solidFill>
+                <a:latin typeface="Segoe UI" pitchFamily="34" charset="0"/>
+                <a:ea typeface="Segoe UI" pitchFamily="34" charset="-122"/>
+                <a:cs typeface="Segoe UI" pitchFamily="34" charset="-120"/>
+              </a:rPr>
+              <a:t>Transformamos datos abiertos de datos.gov.co mediante IA que perfila, grafica y predice tendencias automáticamente, eliminando la barrera técnica para que gobiernos y ciudadanos tomen decisiones ejecutivas en segundos.</a:t>
+            </a:r>
+            <a:endParaRPr lang="en-US" sz="1400" dirty="0"/>
+          </a:p>
+        </p:txBody>
+      </p:sp>
+      <p:sp>
+        <p:nvSpPr>
+          <p:cNvPr id="8" name="Text 5"/>
+          <p:cNvSpPr/>
+          <p:nvPr/>
+        </p:nvSpPr>
+        <p:spPr>
+          <a:xfrm>
+            <a:off x="822960" y="4343400"/>
+            <a:ext cx="7498080" cy="457200"/>
+          </a:xfrm>
+          <a:prstGeom prst="rect">
+            <a:avLst/>
+          </a:prstGeom>
+          <a:noFill/>
+          <a:ln/>
+        </p:spPr>
+        <p:txBody>
+          <a:bodyPr wrap="square" lIns="0" tIns="0" rIns="0" bIns="0" rtlCol="0" anchor="ctr"/>
+          <a:lstStyle/>
+          <a:p>
+            <a:pPr indent="0" marL="0">
+              <a:buNone/>
+            </a:pPr>
+            <a:r>
+              <a:rPr lang="en-US" sz="1500" dirty="0">
+                <a:solidFill>
+                  <a:srgbClr val="94A3B8"/>
+                </a:solidFill>
+                <a:latin typeface="Segoe UI" pitchFamily="34" charset="0"/>
+                <a:ea typeface="Segoe UI" pitchFamily="34" charset="-122"/>
+                <a:cs typeface="Segoe UI" pitchFamily="34" charset="-120"/>
+              </a:rPr>
+              <a:t>Concurso Datos al Ecosistema 2026 · Innovación y Tecnología</a:t>
+            </a:r>
+            <a:endParaRPr lang="en-US" sz="1500" dirty="0"/>
+          </a:p>
+        </p:txBody>
+      </p:sp>
+      <p:sp>
+        <p:nvSpPr>
           <p:cNvPr id="9" name="Text 6"/>
-          <p:cNvSpPr/>
-          <p:nvPr/>
-        </p:nvSpPr>
-        <p:spPr>
-          <a:xfrm>
-            <a:off x="1783080" y="4956048"/>
-            <a:ext cx="5486400" cy="320040"/>
-          </a:xfrm>
-          <a:prstGeom prst="rect">
-            <a:avLst/>
-          </a:prstGeom>
-          <a:noFill/>
-          <a:ln/>
-        </p:spPr>
-        <p:txBody>
-          <a:bodyPr wrap="square" lIns="0" tIns="0" rIns="0" bIns="0" rtlCol="0" anchor="ctr"/>
-          <a:lstStyle/>
-          <a:p>
-            <a:pPr indent="0" marL="0">
-              <a:buNone/>
-            </a:pPr>
-            <a:r>
-              <a:rPr lang="en-US" sz="1300" b="1" dirty="0">
-                <a:solidFill>
-                  <a:srgbClr val="FFFFFF"/>
-                </a:solidFill>
-                <a:latin typeface="Segoe UI" pitchFamily="34" charset="0"/>
-                <a:ea typeface="Segoe UI" pitchFamily="34" charset="-122"/>
-                <a:cs typeface="Segoe UI" pitchFamily="34" charset="-120"/>
-              </a:rPr>
-              <a:t>Generador de Lienzos Ejecutivos</a:t>
-            </a:r>
-            <a:endParaRPr lang="en-US" sz="1300" dirty="0"/>
-          </a:p>
-        </p:txBody>
-      </p:sp>
-      <p:sp>
-        <p:nvSpPr>
-          <p:cNvPr id="10" name="Text 7"/>
-          <p:cNvSpPr/>
-          <p:nvPr/>
-        </p:nvSpPr>
-        <p:spPr>
-          <a:xfrm>
-            <a:off x="1783080" y="5248656"/>
-            <a:ext cx="5486400" cy="274320"/>
-          </a:xfrm>
-          <a:prstGeom prst="rect">
-            <a:avLst/>
-          </a:prstGeom>
-          <a:noFill/>
-          <a:ln/>
-        </p:spPr>
-        <p:txBody>
-          <a:bodyPr wrap="square" lIns="0" tIns="0" rIns="0" bIns="0" rtlCol="0" anchor="ctr"/>
-          <a:lstStyle/>
-          <a:p>
-            <a:pPr indent="0" marL="0">
-              <a:buNone/>
-            </a:pPr>
-            <a:r>
-              <a:rPr lang="en-US" sz="1100" dirty="0">
-                <a:solidFill>
-                  <a:srgbClr val="94A3B8"/>
-                </a:solidFill>
-                <a:latin typeface="Segoe UI" pitchFamily="34" charset="0"/>
-                <a:ea typeface="Segoe UI" pitchFamily="34" charset="-122"/>
-                <a:cs typeface="Segoe UI" pitchFamily="34" charset="-120"/>
-              </a:rPr>
-              <a:t>Datos abiertos + IA, en el navegador</a:t>
-            </a:r>
-            <a:endParaRPr lang="en-US" sz="1100" dirty="0"/>
-          </a:p>
-        </p:txBody>
-      </p:sp>
-      <p:sp>
-        <p:nvSpPr>
-          <p:cNvPr id="11" name="Text 8"/>
           <p:cNvSpPr/>
           <p:nvPr/>
         </p:nvSpPr>
@@ -2070,245 +1997,21 @@
         </p:nvSpPr>
         <p:spPr>
           <a:xfrm>
-            <a:off x="-1828800" y="-2286000"/>
-            <a:ext cx="5486400" cy="5486400"/>
-          </a:xfrm>
-          <a:prstGeom prst="ellipse">
-            <a:avLst/>
-          </a:prstGeom>
-          <a:solidFill>
-            <a:srgbClr val="1E3A5F">
-              <a:alpha val="45000"/>
-            </a:srgbClr>
-          </a:solidFill>
-          <a:ln/>
-        </p:spPr>
-      </p:sp>
-      <p:sp>
-        <p:nvSpPr>
-          <p:cNvPr id="3" name="Text 1"/>
-          <p:cNvSpPr/>
-          <p:nvPr/>
-        </p:nvSpPr>
-        <p:spPr>
-          <a:xfrm>
-            <a:off x="822960" y="1371600"/>
-            <a:ext cx="10515600" cy="1463040"/>
-          </a:xfrm>
-          <a:prstGeom prst="rect">
-            <a:avLst/>
-          </a:prstGeom>
-          <a:noFill/>
-          <a:ln/>
-        </p:spPr>
-        <p:txBody>
-          <a:bodyPr wrap="square" lIns="0" tIns="0" rIns="0" bIns="0" rtlCol="0" anchor="ctr"/>
-          <a:lstStyle/>
-          <a:p>
-            <a:pPr indent="0" marL="0">
-              <a:lnSpc>
-                <a:spcPts val="3800"/>
-              </a:lnSpc>
-              <a:buNone/>
-            </a:pPr>
-            <a:r>
-              <a:rPr lang="en-US" sz="3200" b="1" dirty="0">
-                <a:solidFill>
-                  <a:srgbClr val="FFFFFF"/>
-                </a:solidFill>
-                <a:latin typeface="Segoe UI" pitchFamily="34" charset="0"/>
-                <a:ea typeface="Segoe UI" pitchFamily="34" charset="-122"/>
-                <a:cs typeface="Segoe UI" pitchFamily="34" charset="-120"/>
-              </a:rPr>
-              <a:t>Transformando Datos Abiertos</a:t>
-            </a:r>
-            <a:endParaRPr lang="en-US" sz="3200" dirty="0"/>
-          </a:p>
-          <a:p>
-            <a:pPr indent="0" marL="0">
-              <a:lnSpc>
-                <a:spcPts val="3800"/>
-              </a:lnSpc>
-              <a:buNone/>
-            </a:pPr>
-            <a:r>
-              <a:rPr lang="en-US" sz="3200" b="1" dirty="0">
-                <a:solidFill>
-                  <a:srgbClr val="FFFFFF"/>
-                </a:solidFill>
-                <a:latin typeface="Segoe UI" pitchFamily="34" charset="0"/>
-                <a:ea typeface="Segoe UI" pitchFamily="34" charset="-122"/>
-                <a:cs typeface="Segoe UI" pitchFamily="34" charset="-120"/>
-              </a:rPr>
-              <a:t>en Conocimiento Accionable</a:t>
-            </a:r>
-            <a:endParaRPr lang="en-US" sz="3200" dirty="0"/>
-          </a:p>
-        </p:txBody>
-      </p:sp>
-      <p:sp>
-        <p:nvSpPr>
-          <p:cNvPr id="4" name="Text 2"/>
-          <p:cNvSpPr/>
-          <p:nvPr/>
-        </p:nvSpPr>
-        <p:spPr>
-          <a:xfrm>
-            <a:off x="822960" y="3063240"/>
-            <a:ext cx="9601200" cy="548640"/>
-          </a:xfrm>
-          <a:prstGeom prst="rect">
-            <a:avLst/>
-          </a:prstGeom>
-          <a:noFill/>
-          <a:ln/>
-        </p:spPr>
-        <p:txBody>
-          <a:bodyPr wrap="square" lIns="0" tIns="0" rIns="0" bIns="0" rtlCol="0" anchor="ctr"/>
-          <a:lstStyle/>
-          <a:p>
-            <a:pPr indent="0" marL="0">
-              <a:buNone/>
-            </a:pPr>
-            <a:r>
-              <a:rPr lang="en-US" sz="1700" i="1" dirty="0">
-                <a:solidFill>
-                  <a:srgbClr val="0EA5E9"/>
-                </a:solidFill>
-                <a:latin typeface="Segoe UI" pitchFamily="34" charset="0"/>
-                <a:ea typeface="Segoe UI" pitchFamily="34" charset="-122"/>
-                <a:cs typeface="Segoe UI" pitchFamily="34" charset="-120"/>
-              </a:rPr>
-              <a:t>“La transparencia solo es útil cuando se entiende.”</a:t>
-            </a:r>
-            <a:endParaRPr lang="en-US" sz="1700" dirty="0"/>
-          </a:p>
-        </p:txBody>
-      </p:sp>
-      <p:sp>
-        <p:nvSpPr>
-          <p:cNvPr id="5" name="Shape 3"/>
-          <p:cNvSpPr/>
-          <p:nvPr/>
-        </p:nvSpPr>
-        <p:spPr>
-          <a:xfrm>
-            <a:off x="822960" y="3931920"/>
-            <a:ext cx="2926080" cy="0"/>
-          </a:xfrm>
-          <a:prstGeom prst="line">
-            <a:avLst/>
-          </a:prstGeom>
-          <a:noFill/>
-          <a:ln w="12700">
-            <a:solidFill>
-              <a:srgbClr val="334155"/>
-            </a:solidFill>
-            <a:prstDash val="solid"/>
-          </a:ln>
-        </p:spPr>
-      </p:sp>
-      <p:sp>
-        <p:nvSpPr>
-          <p:cNvPr id="6" name="Text 4"/>
-          <p:cNvSpPr/>
-          <p:nvPr/>
-        </p:nvSpPr>
-        <p:spPr>
-          <a:xfrm>
-            <a:off x="822960" y="4160520"/>
-            <a:ext cx="7315200" cy="274320"/>
-          </a:xfrm>
-          <a:prstGeom prst="rect">
-            <a:avLst/>
-          </a:prstGeom>
-          <a:noFill/>
-          <a:ln/>
-        </p:spPr>
-        <p:txBody>
-          <a:bodyPr wrap="square" lIns="0" tIns="0" rIns="0" bIns="0" rtlCol="0" anchor="ctr"/>
-          <a:lstStyle/>
-          <a:p>
-            <a:pPr indent="0" marL="0">
-              <a:buNone/>
-            </a:pPr>
-            <a:r>
-              <a:rPr lang="en-US" sz="1100" b="1" spc="150" kern="0" dirty="0">
-                <a:solidFill>
-                  <a:srgbClr val="0EA5E9"/>
-                </a:solidFill>
-                <a:latin typeface="Segoe UI" pitchFamily="34" charset="0"/>
-                <a:ea typeface="Segoe UI" pitchFamily="34" charset="-122"/>
-                <a:cs typeface="Segoe UI" pitchFamily="34" charset="-120"/>
-              </a:rPr>
-              <a:t>MUNICIPIO DE EL ROSAL, CUNDINAMARCA</a:t>
-            </a:r>
-            <a:endParaRPr lang="en-US" sz="1100" dirty="0"/>
-          </a:p>
-        </p:txBody>
-      </p:sp>
-      <p:sp>
-        <p:nvSpPr>
-          <p:cNvPr id="7" name="Text 5"/>
-          <p:cNvSpPr/>
-          <p:nvPr/>
-        </p:nvSpPr>
-        <p:spPr>
-          <a:xfrm>
-            <a:off x="822960" y="4434840"/>
-            <a:ext cx="7315200" cy="274320"/>
-          </a:xfrm>
-          <a:prstGeom prst="rect">
-            <a:avLst/>
-          </a:prstGeom>
-          <a:noFill/>
-          <a:ln/>
-        </p:spPr>
-        <p:txBody>
-          <a:bodyPr wrap="square" lIns="0" tIns="0" rIns="0" bIns="0" rtlCol="0" anchor="ctr"/>
-          <a:lstStyle/>
-          <a:p>
-            <a:pPr indent="0" marL="0">
-              <a:buNone/>
-            </a:pPr>
-            <a:r>
-              <a:rPr lang="en-US" sz="1200" dirty="0">
-                <a:solidFill>
-                  <a:srgbClr val="CBD5E1"/>
-                </a:solidFill>
-                <a:latin typeface="Segoe UI" pitchFamily="34" charset="0"/>
-                <a:ea typeface="Segoe UI" pitchFamily="34" charset="-122"/>
-                <a:cs typeface="Segoe UI" pitchFamily="34" charset="-120"/>
-              </a:rPr>
-              <a:t>Concurso Datos al Ecosistema 2026 — Innovación y Tecnología</a:t>
-            </a:r>
-            <a:endParaRPr lang="en-US" sz="1200" dirty="0"/>
-          </a:p>
-        </p:txBody>
-      </p:sp>
-      <p:sp>
-        <p:nvSpPr>
-          <p:cNvPr id="8" name="Shape 6"/>
-          <p:cNvSpPr/>
-          <p:nvPr/>
-        </p:nvSpPr>
-        <p:spPr>
-          <a:xfrm>
-            <a:off x="822960" y="4983480"/>
-            <a:ext cx="457200" cy="457200"/>
-          </a:xfrm>
-          <a:prstGeom prst="ellipse">
-            <a:avLst/>
-          </a:prstGeom>
-          <a:solidFill>
-            <a:srgbClr val="0EA5E9"/>
+            <a:off x="8686800" y="0"/>
+            <a:ext cx="3502152" cy="6858000"/>
+          </a:xfrm>
+          <a:prstGeom prst="rect">
+            <a:avLst/>
+          </a:prstGeom>
+          <a:solidFill>
+            <a:srgbClr val="FFFFFF"/>
           </a:solidFill>
           <a:ln/>
         </p:spPr>
       </p:sp>
       <p:pic>
         <p:nvPicPr>
-          <p:cNvPr id="9" name="Image 0" descr="/home/claude/pptx-lienzo/icons/mail.png">    </p:cNvPr>
+          <p:cNvPr id="3" name="Image 0" descr="/home/claude/pptx-lienzo/logo/logo-completo-verificado.png">    </p:cNvPr>
           <p:cNvPicPr>
             <a:picLocks noChangeAspect="1"/>
           </p:cNvPicPr>
@@ -2322,7 +2025,269 @@
         </p:blipFill>
         <p:spPr>
           <a:xfrm>
-            <a:off x="937260" y="5097780"/>
+            <a:off x="9249156" y="1983020"/>
+            <a:ext cx="2377440" cy="2891961"/>
+          </a:xfrm>
+          <a:prstGeom prst="rect">
+            <a:avLst/>
+          </a:prstGeom>
+        </p:spPr>
+      </p:pic>
+      <p:sp>
+        <p:nvSpPr>
+          <p:cNvPr id="4" name="Text 1"/>
+          <p:cNvSpPr/>
+          <p:nvPr/>
+        </p:nvSpPr>
+        <p:spPr>
+          <a:xfrm>
+            <a:off x="822960" y="1188720"/>
+            <a:ext cx="7498080" cy="685800"/>
+          </a:xfrm>
+          <a:prstGeom prst="rect">
+            <a:avLst/>
+          </a:prstGeom>
+          <a:noFill/>
+          <a:ln/>
+        </p:spPr>
+        <p:txBody>
+          <a:bodyPr wrap="square" lIns="0" tIns="0" rIns="0" bIns="0" rtlCol="0" anchor="ctr"/>
+          <a:lstStyle/>
+          <a:p>
+            <a:pPr indent="0" marL="0">
+              <a:buNone/>
+            </a:pPr>
+            <a:r>
+              <a:rPr lang="en-US" sz="4000" b="1" dirty="0">
+                <a:solidFill>
+                  <a:srgbClr val="FFFFFF"/>
+                </a:solidFill>
+                <a:latin typeface="Segoe UI" pitchFamily="34" charset="0"/>
+                <a:ea typeface="Segoe UI" pitchFamily="34" charset="-122"/>
+                <a:cs typeface="Segoe UI" pitchFamily="34" charset="-120"/>
+              </a:rPr>
+              <a:t>Rosal BI.</a:t>
+            </a:r>
+            <a:endParaRPr lang="en-US" sz="4000" dirty="0"/>
+          </a:p>
+        </p:txBody>
+      </p:sp>
+      <p:sp>
+        <p:nvSpPr>
+          <p:cNvPr id="5" name="Text 2"/>
+          <p:cNvSpPr/>
+          <p:nvPr/>
+        </p:nvSpPr>
+        <p:spPr>
+          <a:xfrm>
+            <a:off x="822960" y="1874520"/>
+            <a:ext cx="7498080" cy="365760"/>
+          </a:xfrm>
+          <a:prstGeom prst="rect">
+            <a:avLst/>
+          </a:prstGeom>
+          <a:noFill/>
+          <a:ln/>
+        </p:spPr>
+        <p:txBody>
+          <a:bodyPr wrap="square" lIns="0" tIns="0" rIns="0" bIns="0" rtlCol="0" anchor="ctr"/>
+          <a:lstStyle/>
+          <a:p>
+            <a:pPr indent="0" marL="0">
+              <a:buNone/>
+            </a:pPr>
+            <a:r>
+              <a:rPr lang="en-US" sz="1500" b="1" spc="100" kern="0" dirty="0">
+                <a:solidFill>
+                  <a:srgbClr val="FFFFFF"/>
+                </a:solidFill>
+                <a:latin typeface="Segoe UI" pitchFamily="34" charset="0"/>
+                <a:ea typeface="Segoe UI" pitchFamily="34" charset="-122"/>
+                <a:cs typeface="Segoe UI" pitchFamily="34" charset="-120"/>
+              </a:rPr>
+              <a:t>DATOS QUE TRANSFORMAN</a:t>
+            </a:r>
+            <a:endParaRPr lang="en-US" sz="1500" dirty="0"/>
+          </a:p>
+        </p:txBody>
+      </p:sp>
+      <p:sp>
+        <p:nvSpPr>
+          <p:cNvPr id="6" name="Text 3"/>
+          <p:cNvSpPr/>
+          <p:nvPr/>
+        </p:nvSpPr>
+        <p:spPr>
+          <a:xfrm>
+            <a:off x="822960" y="2514600"/>
+            <a:ext cx="7315200" cy="548640"/>
+          </a:xfrm>
+          <a:prstGeom prst="rect">
+            <a:avLst/>
+          </a:prstGeom>
+          <a:noFill/>
+          <a:ln/>
+        </p:spPr>
+        <p:txBody>
+          <a:bodyPr wrap="square" lIns="0" tIns="0" rIns="0" bIns="0" rtlCol="0" anchor="ctr"/>
+          <a:lstStyle/>
+          <a:p>
+            <a:pPr indent="0" marL="0">
+              <a:buNone/>
+            </a:pPr>
+            <a:r>
+              <a:rPr lang="en-US" sz="1600" i="1" dirty="0">
+                <a:solidFill>
+                  <a:srgbClr val="0EA5E9"/>
+                </a:solidFill>
+                <a:latin typeface="Segoe UI" pitchFamily="34" charset="0"/>
+                <a:ea typeface="Segoe UI" pitchFamily="34" charset="-122"/>
+                <a:cs typeface="Segoe UI" pitchFamily="34" charset="-120"/>
+              </a:rPr>
+              <a:t>“La transparencia solo es útil cuando se entiende.”</a:t>
+            </a:r>
+            <a:endParaRPr lang="en-US" sz="1600" dirty="0"/>
+          </a:p>
+        </p:txBody>
+      </p:sp>
+      <p:sp>
+        <p:nvSpPr>
+          <p:cNvPr id="7" name="Shape 4"/>
+          <p:cNvSpPr/>
+          <p:nvPr/>
+        </p:nvSpPr>
+        <p:spPr>
+          <a:xfrm>
+            <a:off x="822960" y="3429000"/>
+            <a:ext cx="2926080" cy="0"/>
+          </a:xfrm>
+          <a:prstGeom prst="line">
+            <a:avLst/>
+          </a:prstGeom>
+          <a:noFill/>
+          <a:ln w="12700">
+            <a:solidFill>
+              <a:srgbClr val="334155"/>
+            </a:solidFill>
+            <a:prstDash val="solid"/>
+          </a:ln>
+        </p:spPr>
+      </p:sp>
+      <p:sp>
+        <p:nvSpPr>
+          <p:cNvPr id="8" name="Text 5"/>
+          <p:cNvSpPr/>
+          <p:nvPr/>
+        </p:nvSpPr>
+        <p:spPr>
+          <a:xfrm>
+            <a:off x="822960" y="3657600"/>
+            <a:ext cx="7315200" cy="274320"/>
+          </a:xfrm>
+          <a:prstGeom prst="rect">
+            <a:avLst/>
+          </a:prstGeom>
+          <a:noFill/>
+          <a:ln/>
+        </p:spPr>
+        <p:txBody>
+          <a:bodyPr wrap="square" lIns="0" tIns="0" rIns="0" bIns="0" rtlCol="0" anchor="ctr"/>
+          <a:lstStyle/>
+          <a:p>
+            <a:pPr indent="0" marL="0">
+              <a:buNone/>
+            </a:pPr>
+            <a:r>
+              <a:rPr lang="en-US" sz="1100" b="1" spc="150" kern="0" dirty="0">
+                <a:solidFill>
+                  <a:srgbClr val="0EA5E9"/>
+                </a:solidFill>
+                <a:latin typeface="Segoe UI" pitchFamily="34" charset="0"/>
+                <a:ea typeface="Segoe UI" pitchFamily="34" charset="-122"/>
+                <a:cs typeface="Segoe UI" pitchFamily="34" charset="-120"/>
+              </a:rPr>
+              <a:t>MUNICIPIO DE EL ROSAL, CUNDINAMARCA</a:t>
+            </a:r>
+            <a:endParaRPr lang="en-US" sz="1100" dirty="0"/>
+          </a:p>
+        </p:txBody>
+      </p:sp>
+      <p:sp>
+        <p:nvSpPr>
+          <p:cNvPr id="9" name="Text 6"/>
+          <p:cNvSpPr/>
+          <p:nvPr/>
+        </p:nvSpPr>
+        <p:spPr>
+          <a:xfrm>
+            <a:off x="822960" y="3931920"/>
+            <a:ext cx="7315200" cy="274320"/>
+          </a:xfrm>
+          <a:prstGeom prst="rect">
+            <a:avLst/>
+          </a:prstGeom>
+          <a:noFill/>
+          <a:ln/>
+        </p:spPr>
+        <p:txBody>
+          <a:bodyPr wrap="square" lIns="0" tIns="0" rIns="0" bIns="0" rtlCol="0" anchor="ctr"/>
+          <a:lstStyle/>
+          <a:p>
+            <a:pPr indent="0" marL="0">
+              <a:buNone/>
+            </a:pPr>
+            <a:r>
+              <a:rPr lang="en-US" sz="1200" dirty="0">
+                <a:solidFill>
+                  <a:srgbClr val="CBD5E1"/>
+                </a:solidFill>
+                <a:latin typeface="Segoe UI" pitchFamily="34" charset="0"/>
+                <a:ea typeface="Segoe UI" pitchFamily="34" charset="-122"/>
+                <a:cs typeface="Segoe UI" pitchFamily="34" charset="-120"/>
+              </a:rPr>
+              <a:t>Concurso Datos al Ecosistema 2026 — Innovación y Tecnología</a:t>
+            </a:r>
+            <a:endParaRPr lang="en-US" sz="1200" dirty="0"/>
+          </a:p>
+        </p:txBody>
+      </p:sp>
+      <p:sp>
+        <p:nvSpPr>
+          <p:cNvPr id="10" name="Shape 7"/>
+          <p:cNvSpPr/>
+          <p:nvPr/>
+        </p:nvSpPr>
+        <p:spPr>
+          <a:xfrm>
+            <a:off x="822960" y="4480560"/>
+            <a:ext cx="457200" cy="457200"/>
+          </a:xfrm>
+          <a:prstGeom prst="ellipse">
+            <a:avLst/>
+          </a:prstGeom>
+          <a:solidFill>
+            <a:srgbClr val="0EA5E9"/>
+          </a:solidFill>
+          <a:ln/>
+        </p:spPr>
+      </p:sp>
+      <p:pic>
+        <p:nvPicPr>
+          <p:cNvPr id="11" name="Image 1" descr="/home/claude/pptx-lienzo/icons/mail.png">    </p:cNvPr>
+          <p:cNvPicPr>
+            <a:picLocks noChangeAspect="1"/>
+          </p:cNvPicPr>
+          <p:nvPr/>
+        </p:nvPicPr>
+        <p:blipFill>
+          <a:blip r:embed="rId2"/>
+          <a:stretch>
+            <a:fillRect/>
+          </a:stretch>
+        </p:blipFill>
+        <p:spPr>
+          <a:xfrm>
+            <a:off x="937260" y="4594860"/>
             <a:ext cx="228600" cy="228600"/>
           </a:xfrm>
           <a:prstGeom prst="rect">
@@ -2332,13 +2297,13 @@
       </p:pic>
       <p:sp>
         <p:nvSpPr>
-          <p:cNvPr id="10" name="Text 7"/>
-          <p:cNvSpPr/>
-          <p:nvPr/>
-        </p:nvSpPr>
-        <p:spPr>
-          <a:xfrm>
-            <a:off x="1417320" y="4983480"/>
+          <p:cNvPr id="12" name="Text 8"/>
+          <p:cNvSpPr/>
+          <p:nvPr/>
+        </p:nvSpPr>
+        <p:spPr>
+          <a:xfrm>
+            <a:off x="1417320" y="4480560"/>
             <a:ext cx="5486400" cy="457200"/>
           </a:xfrm>
           <a:prstGeom prst="rect">
@@ -2371,13 +2336,13 @@
       </p:sp>
       <p:sp>
         <p:nvSpPr>
-          <p:cNvPr id="11" name="Text 8"/>
-          <p:cNvSpPr/>
-          <p:nvPr/>
-        </p:nvSpPr>
-        <p:spPr>
-          <a:xfrm>
-            <a:off x="822960" y="5852160"/>
+          <p:cNvPr id="13" name="Text 9"/>
+          <p:cNvSpPr/>
+          <p:nvPr/>
+        </p:nvSpPr>
+        <p:spPr>
+          <a:xfrm>
+            <a:off x="822960" y="5349240"/>
             <a:ext cx="5486400" cy="457200"/>
           </a:xfrm>
           <a:prstGeom prst="rect">
@@ -2410,7 +2375,7 @@
       </p:sp>
       <p:sp>
         <p:nvSpPr>
-          <p:cNvPr id="12" name="Text 9"/>
+          <p:cNvPr id="14" name="Text 10"/>
           <p:cNvSpPr/>
           <p:nvPr/>
         </p:nvSpPr>
@@ -3709,15 +3674,39 @@
                 <a:ea typeface="Segoe UI" pitchFamily="34" charset="-122"/>
                 <a:cs typeface="Segoe UI" pitchFamily="34" charset="-120"/>
               </a:rPr>
-              <a:t>EL ROSAL · LIENZO EJECUTIVO</a:t>
+              <a:t>ROSAL BI · DATOS QUE TRANSFORMAN</a:t>
             </a:r>
             <a:endParaRPr lang="en-US" sz="950" dirty="0"/>
           </a:p>
         </p:txBody>
       </p:sp>
-      <p:sp>
-        <p:nvSpPr>
-          <p:cNvPr id="50" name="Text 44"/>
+      <p:pic>
+        <p:nvPicPr>
+          <p:cNvPr id="50" name="Image 4" descr="/home/claude/pptx-lienzo/logo/logo-app.png">    </p:cNvPr>
+          <p:cNvPicPr>
+            <a:picLocks noChangeAspect="1"/>
+          </p:cNvPicPr>
+          <p:nvPr/>
+        </p:nvPicPr>
+        <p:blipFill>
+          <a:blip r:embed="rId5"/>
+          <a:stretch>
+            <a:fillRect/>
+          </a:stretch>
+        </p:blipFill>
+        <p:spPr>
+          <a:xfrm>
+            <a:off x="10863072" y="384048"/>
+            <a:ext cx="777240" cy="777240"/>
+          </a:xfrm>
+          <a:prstGeom prst="rect">
+            <a:avLst/>
+          </a:prstGeom>
+        </p:spPr>
+      </p:pic>
+      <p:sp>
+        <p:nvSpPr>
+          <p:cNvPr id="51" name="Text 44"/>
           <p:cNvSpPr/>
           <p:nvPr/>
         </p:nvSpPr>
@@ -4663,15 +4652,39 @@
                 <a:ea typeface="Segoe UI" pitchFamily="34" charset="-122"/>
                 <a:cs typeface="Segoe UI" pitchFamily="34" charset="-120"/>
               </a:rPr>
-              <a:t>EL ROSAL · LIENZO EJECUTIVO</a:t>
+              <a:t>ROSAL BI · DATOS QUE TRANSFORMAN</a:t>
             </a:r>
             <a:endParaRPr lang="en-US" sz="950" dirty="0"/>
           </a:p>
         </p:txBody>
       </p:sp>
-      <p:sp>
-        <p:nvSpPr>
-          <p:cNvPr id="31" name="Text 23"/>
+      <p:pic>
+        <p:nvPicPr>
+          <p:cNvPr id="31" name="Image 6" descr="/home/claude/pptx-lienzo/logo/logo-app.png">    </p:cNvPr>
+          <p:cNvPicPr>
+            <a:picLocks noChangeAspect="1"/>
+          </p:cNvPicPr>
+          <p:nvPr/>
+        </p:nvPicPr>
+        <p:blipFill>
+          <a:blip r:embed="rId7"/>
+          <a:stretch>
+            <a:fillRect/>
+          </a:stretch>
+        </p:blipFill>
+        <p:spPr>
+          <a:xfrm>
+            <a:off x="10863072" y="384048"/>
+            <a:ext cx="777240" cy="777240"/>
+          </a:xfrm>
+          <a:prstGeom prst="rect">
+            <a:avLst/>
+          </a:prstGeom>
+        </p:spPr>
+      </p:pic>
+      <p:sp>
+        <p:nvSpPr>
+          <p:cNvPr id="32" name="Text 23"/>
           <p:cNvSpPr/>
           <p:nvPr/>
         </p:nvSpPr>
@@ -5831,15 +5844,39 @@
                 <a:ea typeface="Segoe UI" pitchFamily="34" charset="-122"/>
                 <a:cs typeface="Segoe UI" pitchFamily="34" charset="-120"/>
               </a:rPr>
-              <a:t>EL ROSAL · LIENZO EJECUTIVO</a:t>
+              <a:t>ROSAL BI · DATOS QUE TRANSFORMAN</a:t>
             </a:r>
             <a:endParaRPr lang="en-US" sz="950" dirty="0"/>
           </a:p>
         </p:txBody>
       </p:sp>
-      <p:sp>
-        <p:nvSpPr>
-          <p:cNvPr id="34" name="Text 28"/>
+      <p:pic>
+        <p:nvPicPr>
+          <p:cNvPr id="34" name="Image 4" descr="/home/claude/pptx-lienzo/logo/logo-app.png">    </p:cNvPr>
+          <p:cNvPicPr>
+            <a:picLocks noChangeAspect="1"/>
+          </p:cNvPicPr>
+          <p:nvPr/>
+        </p:nvPicPr>
+        <p:blipFill>
+          <a:blip r:embed="rId5"/>
+          <a:stretch>
+            <a:fillRect/>
+          </a:stretch>
+        </p:blipFill>
+        <p:spPr>
+          <a:xfrm>
+            <a:off x="10863072" y="384048"/>
+            <a:ext cx="777240" cy="777240"/>
+          </a:xfrm>
+          <a:prstGeom prst="rect">
+            <a:avLst/>
+          </a:prstGeom>
+        </p:spPr>
+      </p:pic>
+      <p:sp>
+        <p:nvSpPr>
+          <p:cNvPr id="35" name="Text 28"/>
           <p:cNvSpPr/>
           <p:nvPr/>
         </p:nvSpPr>
@@ -6258,7 +6295,7 @@
       </p:sp>
       <p:pic>
         <p:nvPicPr>
-          <p:cNvPr id="13" name="Image 2" descr="/home/claude/pptx-lienzo/icons/sliders.png">    </p:cNvPr>
+          <p:cNvPr id="13" name="Image 2" descr="/home/claude/pptx-lienzo/icons/trending.png">    </p:cNvPr>
           <p:cNvPicPr>
             <a:picLocks noChangeAspect="1"/>
           </p:cNvPicPr>
@@ -6313,7 +6350,7 @@
                 <a:ea typeface="Segoe UI" pitchFamily="34" charset="-122"/>
                 <a:cs typeface="Segoe UI" pitchFamily="34" charset="-120"/>
               </a:rPr>
-              <a:t>Flexibilidad total</a:t>
+              <a:t>Estadística real, no solo reglas</a:t>
             </a:r>
             <a:endParaRPr lang="en-US" sz="1600" dirty="0"/>
           </a:p>
@@ -6355,7 +6392,7 @@
                 <a:ea typeface="Segoe UI" pitchFamily="34" charset="-122"/>
                 <a:cs typeface="Segoe UI" pitchFamily="34" charset="-120"/>
               </a:rPr>
-              <a:t>El usuario ajusta cualquier sugerencia con menús simples, sin tocar código.</a:t>
+              <a:t>Desviación estándar, correlación entre variables y detección de valores atípicos — todo calculado, nunca inventado.</a:t>
             </a:r>
             <a:endParaRPr lang="en-US" sz="1250" dirty="0"/>
           </a:p>
@@ -7102,15 +7139,39 @@
                 <a:ea typeface="Segoe UI" pitchFamily="34" charset="-122"/>
                 <a:cs typeface="Segoe UI" pitchFamily="34" charset="-120"/>
               </a:rPr>
-              <a:t>EL ROSAL · LIENZO EJECUTIVO</a:t>
+              <a:t>ROSAL BI · DATOS QUE TRANSFORMAN</a:t>
             </a:r>
             <a:endParaRPr lang="en-US" sz="950" dirty="0"/>
           </a:p>
         </p:txBody>
       </p:sp>
-      <p:sp>
-        <p:nvSpPr>
-          <p:cNvPr id="39" name="Text 34"/>
+      <p:pic>
+        <p:nvPicPr>
+          <p:cNvPr id="39" name="Image 3" descr="/home/claude/pptx-lienzo/logo/logo-app.png">    </p:cNvPr>
+          <p:cNvPicPr>
+            <a:picLocks noChangeAspect="1"/>
+          </p:cNvPicPr>
+          <p:nvPr/>
+        </p:nvPicPr>
+        <p:blipFill>
+          <a:blip r:embed="rId4"/>
+          <a:stretch>
+            <a:fillRect/>
+          </a:stretch>
+        </p:blipFill>
+        <p:spPr>
+          <a:xfrm>
+            <a:off x="10863072" y="384048"/>
+            <a:ext cx="777240" cy="777240"/>
+          </a:xfrm>
+          <a:prstGeom prst="rect">
+            <a:avLst/>
+          </a:prstGeom>
+        </p:spPr>
+      </p:pic>
+      <p:sp>
+        <p:nvSpPr>
+          <p:cNvPr id="40" name="Text 34"/>
           <p:cNvSpPr/>
           <p:nvPr/>
         </p:nvSpPr>
@@ -7385,12 +7446,12 @@
           <a:p>
             <a:pPr indent="0" marL="0">
               <a:lnSpc>
-                <a:spcPct val="120000"/>
+                <a:spcPct val="118000"/>
               </a:lnSpc>
               <a:buNone/>
             </a:pPr>
             <a:r>
-              <a:rPr lang="en-US" sz="1100" dirty="0">
+              <a:rPr lang="en-US" sz="1050" dirty="0">
                 <a:solidFill>
                   <a:srgbClr val="CBD5E1"/>
                 </a:solidFill>
@@ -7400,7 +7461,7 @@
               </a:rPr>
               <a:t>Sugiere automáticamente los KPIs y gráficos más relevantes según la estructura de los datos.</a:t>
             </a:r>
-            <a:endParaRPr lang="en-US" sz="1100" dirty="0"/>
+            <a:endParaRPr lang="en-US" sz="1050" dirty="0"/>
           </a:p>
         </p:txBody>
       </p:sp>
@@ -7503,7 +7564,7 @@
                 <a:ea typeface="Segoe UI" pitchFamily="34" charset="-122"/>
                 <a:cs typeface="Segoe UI" pitchFamily="34" charset="-120"/>
               </a:rPr>
-              <a:t>Predictivo</a:t>
+              <a:t>Predictivo con rango real</a:t>
             </a:r>
             <a:endParaRPr lang="en-US" sz="1650" dirty="0"/>
           </a:p>
@@ -7532,12 +7593,12 @@
           <a:p>
             <a:pPr indent="0" marL="0">
               <a:lnSpc>
-                <a:spcPct val="120000"/>
+                <a:spcPct val="118000"/>
               </a:lnSpc>
               <a:buNone/>
             </a:pPr>
             <a:r>
-              <a:rPr lang="en-US" sz="1100" dirty="0">
+              <a:rPr lang="en-US" sz="1050" dirty="0">
                 <a:solidFill>
                   <a:srgbClr val="CBD5E1"/>
                 </a:solidFill>
@@ -7545,9 +7606,9 @@
                 <a:ea typeface="Segoe UI" pitchFamily="34" charset="-122"/>
                 <a:cs typeface="Segoe UI" pitchFamily="34" charset="-120"/>
               </a:rPr>
-              <a:t>Calcula el crecimiento histórico promedio y proyecta el próximo periodo, marcado como "Estimado".</a:t>
-            </a:r>
-            <a:endParaRPr lang="en-US" sz="1100" dirty="0"/>
+              <a:t>Proyecta el próximo periodo con un rango de confianza — no un número falsamente preciso.</a:t>
+            </a:r>
+            <a:endParaRPr lang="en-US" sz="1050" dirty="0"/>
           </a:p>
         </p:txBody>
       </p:sp>
@@ -7595,7 +7656,7 @@
       </p:sp>
       <p:pic>
         <p:nvPicPr>
-          <p:cNvPr id="16" name="Image 2" descr="/home/claude/pptx-lienzo/icons/sliders.png">    </p:cNvPr>
+          <p:cNvPr id="16" name="Image 2" descr="/home/claude/pptx-lienzo/icons/eye.png">    </p:cNvPr>
           <p:cNvPicPr>
             <a:picLocks noChangeAspect="1"/>
           </p:cNvPicPr>
@@ -7650,7 +7711,7 @@
                 <a:ea typeface="Segoe UI" pitchFamily="34" charset="-122"/>
                 <a:cs typeface="Segoe UI" pitchFamily="34" charset="-120"/>
               </a:rPr>
-              <a:t>Control Manual</a:t>
+              <a:t>Narrador Experto (IA)</a:t>
             </a:r>
             <a:endParaRPr lang="en-US" sz="1650" dirty="0"/>
           </a:p>
@@ -7679,12 +7740,12 @@
           <a:p>
             <a:pPr indent="0" marL="0">
               <a:lnSpc>
-                <a:spcPct val="120000"/>
+                <a:spcPct val="118000"/>
               </a:lnSpc>
               <a:buNone/>
             </a:pPr>
             <a:r>
-              <a:rPr lang="en-US" sz="1100" dirty="0">
+              <a:rPr lang="en-US" sz="1050" dirty="0">
                 <a:solidFill>
                   <a:srgbClr val="CBD5E1"/>
                 </a:solidFill>
@@ -7692,9 +7753,9 @@
                 <a:ea typeface="Segoe UI" pitchFamily="34" charset="-122"/>
                 <a:cs typeface="Segoe UI" pitchFamily="34" charset="-120"/>
               </a:rPr>
-              <a:t>El usuario cambia el tipo de gráfico o el KPI propuesto en un clic, sin perder la automatización.</a:t>
-            </a:r>
-            <a:endParaRPr lang="en-US" sz="1100" dirty="0"/>
+              <a:t>Un modelo de lenguaje (vía n8n) explica los hallazgos con contexto institucional real, sin inventar ninguna cifra.</a:t>
+            </a:r>
+            <a:endParaRPr lang="en-US" sz="1050" dirty="0"/>
           </a:p>
         </p:txBody>
       </p:sp>
@@ -7728,8 +7789,8 @@
         </p:nvSpPr>
         <p:spPr>
           <a:xfrm>
-            <a:off x="960120" y="4681728"/>
-            <a:ext cx="10241280" cy="320040"/>
+            <a:off x="960120" y="4645152"/>
+            <a:ext cx="10241280" cy="274320"/>
           </a:xfrm>
           <a:prstGeom prst="rect">
             <a:avLst/>
@@ -8196,7 +8257,7 @@
               <a:buNone/>
             </a:pPr>
             <a:r>
-              <a:rPr lang="en-US" sz="1700" b="1" dirty="0">
+              <a:rPr lang="en-US" sz="1450" b="1" dirty="0">
                 <a:solidFill>
                   <a:srgbClr val="9333EA"/>
                 </a:solidFill>
@@ -8204,54 +8265,39 @@
                 <a:ea typeface="Segoe UI" pitchFamily="34" charset="-122"/>
                 <a:cs typeface="Segoe UI" pitchFamily="34" charset="-120"/>
               </a:rPr>
-              <a:t>$19.480 M</a:t>
-            </a:r>
-            <a:endParaRPr lang="en-US" sz="1700" dirty="0"/>
-          </a:p>
-        </p:txBody>
-      </p:sp>
-      <p:sp>
-        <p:nvSpPr>
-          <p:cNvPr id="33" name="Text 28"/>
-          <p:cNvSpPr/>
-          <p:nvPr/>
-        </p:nvSpPr>
-        <p:spPr>
-          <a:xfrm>
-            <a:off x="10744200" y="5468112"/>
-            <a:ext cx="365760" cy="365760"/>
-          </a:xfrm>
-          <a:prstGeom prst="rect">
-            <a:avLst/>
-          </a:prstGeom>
-          <a:noFill/>
-          <a:ln/>
-        </p:spPr>
-        <p:txBody>
-          <a:bodyPr wrap="square" lIns="0" tIns="0" rIns="0" bIns="0" rtlCol="0" anchor="ctr"/>
-          <a:lstStyle/>
-          <a:p>
-            <a:pPr indent="0" marL="0">
-              <a:buNone/>
-            </a:pPr>
-            <a:r>
-              <a:rPr lang="en-US" sz="1700" b="1" dirty="0">
-                <a:solidFill>
-                  <a:srgbClr val="16A34A"/>
-                </a:solidFill>
-                <a:latin typeface="Segoe UI" pitchFamily="34" charset="0"/>
-                <a:ea typeface="Segoe UI" pitchFamily="34" charset="-122"/>
-                <a:cs typeface="Segoe UI" pitchFamily="34" charset="-120"/>
-              </a:rPr>
-              <a:t>↗</a:t>
-            </a:r>
-            <a:endParaRPr lang="en-US" sz="1700" dirty="0"/>
-          </a:p>
-        </p:txBody>
-      </p:sp>
-      <p:sp>
-        <p:nvSpPr>
-          <p:cNvPr id="34" name="Text 29"/>
+              <a:t>$18.2M – $20.8M</a:t>
+            </a:r>
+            <a:endParaRPr lang="en-US" sz="1450" dirty="0"/>
+          </a:p>
+        </p:txBody>
+      </p:sp>
+      <p:pic>
+        <p:nvPicPr>
+          <p:cNvPr id="33" name="Image 3" descr="/home/claude/pptx-lienzo/logo/logo-app.png">    </p:cNvPr>
+          <p:cNvPicPr>
+            <a:picLocks noChangeAspect="1"/>
+          </p:cNvPicPr>
+          <p:nvPr/>
+        </p:nvPicPr>
+        <p:blipFill>
+          <a:blip r:embed="rId4"/>
+          <a:stretch>
+            <a:fillRect/>
+          </a:stretch>
+        </p:blipFill>
+        <p:spPr>
+          <a:xfrm>
+            <a:off x="10863072" y="384048"/>
+            <a:ext cx="777240" cy="777240"/>
+          </a:xfrm>
+          <a:prstGeom prst="rect">
+            <a:avLst/>
+          </a:prstGeom>
+        </p:spPr>
+      </p:pic>
+      <p:sp>
+        <p:nvSpPr>
+          <p:cNvPr id="34" name="Text 28"/>
           <p:cNvSpPr/>
           <p:nvPr/>
         </p:nvSpPr>
@@ -9338,15 +9384,39 @@
                 <a:ea typeface="Segoe UI" pitchFamily="34" charset="-122"/>
                 <a:cs typeface="Segoe UI" pitchFamily="34" charset="-120"/>
               </a:rPr>
-              <a:t>EL ROSAL · LIENZO EJECUTIVO</a:t>
+              <a:t>ROSAL BI · DATOS QUE TRANSFORMAN</a:t>
             </a:r>
             <a:endParaRPr lang="en-US" sz="950" dirty="0"/>
           </a:p>
         </p:txBody>
       </p:sp>
-      <p:sp>
-        <p:nvSpPr>
-          <p:cNvPr id="35" name="Text 30"/>
+      <p:pic>
+        <p:nvPicPr>
+          <p:cNvPr id="35" name="Image 3" descr="/home/claude/pptx-lienzo/logo/logo-app.png">    </p:cNvPr>
+          <p:cNvPicPr>
+            <a:picLocks noChangeAspect="1"/>
+          </p:cNvPicPr>
+          <p:nvPr/>
+        </p:nvPicPr>
+        <p:blipFill>
+          <a:blip r:embed="rId4"/>
+          <a:stretch>
+            <a:fillRect/>
+          </a:stretch>
+        </p:blipFill>
+        <p:spPr>
+          <a:xfrm>
+            <a:off x="10863072" y="384048"/>
+            <a:ext cx="777240" cy="777240"/>
+          </a:xfrm>
+          <a:prstGeom prst="rect">
+            <a:avLst/>
+          </a:prstGeom>
+        </p:spPr>
+      </p:pic>
+      <p:sp>
+        <p:nvSpPr>
+          <p:cNvPr id="36" name="Text 30"/>
           <p:cNvSpPr/>
           <p:nvPr/>
         </p:nvSpPr>
@@ -10518,15 +10588,39 @@
                 <a:ea typeface="Segoe UI" pitchFamily="34" charset="-122"/>
                 <a:cs typeface="Segoe UI" pitchFamily="34" charset="-120"/>
               </a:rPr>
-              <a:t>EL ROSAL · LIENZO EJECUTIVO</a:t>
+              <a:t>ROSAL BI · DATOS QUE TRANSFORMAN</a:t>
             </a:r>
             <a:endParaRPr lang="en-US" sz="950" dirty="0"/>
           </a:p>
         </p:txBody>
       </p:sp>
-      <p:sp>
-        <p:nvSpPr>
-          <p:cNvPr id="40" name="Text 34"/>
+      <p:pic>
+        <p:nvPicPr>
+          <p:cNvPr id="40" name="Image 4" descr="/home/claude/pptx-lienzo/logo/logo-app.png">    </p:cNvPr>
+          <p:cNvPicPr>
+            <a:picLocks noChangeAspect="1"/>
+          </p:cNvPicPr>
+          <p:nvPr/>
+        </p:nvPicPr>
+        <p:blipFill>
+          <a:blip r:embed="rId5"/>
+          <a:stretch>
+            <a:fillRect/>
+          </a:stretch>
+        </p:blipFill>
+        <p:spPr>
+          <a:xfrm>
+            <a:off x="10863072" y="384048"/>
+            <a:ext cx="777240" cy="777240"/>
+          </a:xfrm>
+          <a:prstGeom prst="rect">
+            <a:avLst/>
+          </a:prstGeom>
+        </p:spPr>
+      </p:pic>
+      <p:sp>
+        <p:nvSpPr>
+          <p:cNvPr id="41" name="Text 34"/>
           <p:cNvSpPr/>
           <p:nvPr/>
         </p:nvSpPr>
@@ -10725,7 +10819,7 @@
               <a:buNone/>
             </a:pPr>
             <a:r>
-              <a:rPr lang="en-US" sz="1400" dirty="0">
+              <a:rPr lang="en-US" sz="1300" dirty="0">
                 <a:solidFill>
                   <a:srgbClr val="94A3B8"/>
                 </a:solidFill>
@@ -10733,15 +10827,39 @@
                 <a:ea typeface="Segoe UI" pitchFamily="34" charset="-122"/>
                 <a:cs typeface="Segoe UI" pitchFamily="34" charset="-120"/>
               </a:rPr>
-              <a:t>datos.gov.co  →  Plan de panel  →  Generar Lienzo  →  Descargar PDF</a:t>
-            </a:r>
-            <a:endParaRPr lang="en-US" sz="1400" dirty="0"/>
-          </a:p>
-        </p:txBody>
-      </p:sp>
-      <p:sp>
-        <p:nvSpPr>
-          <p:cNvPr id="7" name="Text 4"/>
+              <a:t>datos.gov.co → Plan de panel → Generar Lienzo → Preguntarle al Narrador Experto → Descargar PDF</a:t>
+            </a:r>
+            <a:endParaRPr lang="en-US" sz="1300" dirty="0"/>
+          </a:p>
+        </p:txBody>
+      </p:sp>
+      <p:pic>
+        <p:nvPicPr>
+          <p:cNvPr id="7" name="Image 1" descr="/home/claude/pptx-lienzo/logo/logo-app.png">    </p:cNvPr>
+          <p:cNvPicPr>
+            <a:picLocks noChangeAspect="1"/>
+          </p:cNvPicPr>
+          <p:nvPr/>
+        </p:nvPicPr>
+        <p:blipFill>
+          <a:blip r:embed="rId2"/>
+          <a:stretch>
+            <a:fillRect/>
+          </a:stretch>
+        </p:blipFill>
+        <p:spPr>
+          <a:xfrm>
+            <a:off x="10863072" y="384048"/>
+            <a:ext cx="777240" cy="777240"/>
+          </a:xfrm>
+          <a:prstGeom prst="rect">
+            <a:avLst/>
+          </a:prstGeom>
+        </p:spPr>
+      </p:pic>
+      <p:sp>
+        <p:nvSpPr>
+          <p:cNvPr id="8" name="Text 4"/>
           <p:cNvSpPr/>
           <p:nvPr/>
         </p:nvSpPr>

</xml_diff>